<commit_message>
Regenerar PPTX y capturas con Paquetería Internacional/Com. Digitales ocultas
Las capturas y contadores del PPTX quedaron desactualizados tras el
cambio de visibilidad por defecto de esas 2 categorías. Retomadas contra
la URL única del sitio (antes apuntaban a proto-navegable.vercel.app,
ya en desuso).

Co-Authored-By: Claude Sonnet 5 <noreply@anthropic.com>
</commit_message>
<xml_diff>
--- a/hub/presentaciones/presentacion-v1.pptx
+++ b/hub/presentaciones/presentacion-v1.pptx
@@ -3055,7 +3055,7 @@
                 <a:ea typeface="Gilroy" pitchFamily="34" charset="-122"/>
                 <a:cs typeface="Gilroy" pitchFamily="34" charset="-120"/>
               </a:rPr>
-              <a:t>6 categorías visibles, con </a:t>
+              <a:t>4 categorías visibles hoy, con </a:t>
             </a:r>
             <a:pPr indent="0" marL="0">
               <a:lnSpc>
@@ -3089,7 +3089,7 @@
                 <a:ea typeface="Gilroy" pitchFamily="34" charset="-122"/>
                 <a:cs typeface="Gilroy" pitchFamily="34" charset="-120"/>
               </a:rPr>
-              <a:t> en vez de Franquicias.</a:t>
+              <a:t> en vez de Franquicias (mismas 2 ocultas por defecto).</a:t>
             </a:r>
             <a:pPr indent="0" marL="0">
               <a:lnSpc>
@@ -5670,7 +5670,7 @@
                 <a:ea typeface="Gilroy" pitchFamily="34" charset="-122"/>
                 <a:cs typeface="Gilroy" pitchFamily="34" charset="-120"/>
               </a:rPr>
-              <a:t>Paquetería Internacional y Mis Comunicaciones Digitales necesitan gestiones reales que reemplacen el contenido inventado.</a:t>
+              <a:t>Paquetería Internacional y Mis Comunicaciones Digitales necesitan gestiones reales que reemplacen el contenido inventado — hasta entonces quedan ocultas por defecto.</a:t>
             </a:r>
             <a:endParaRPr lang="en-US" sz="1100" dirty="0"/>
           </a:p>
@@ -8792,7 +8792,7 @@
                 <a:ea typeface="Gilroy" pitchFamily="34" charset="-122"/>
                 <a:cs typeface="Gilroy" pitchFamily="34" charset="-120"/>
               </a:rPr>
-              <a:t>17 gestiones</a:t>
+              <a:t>9 gestiones</a:t>
             </a:r>
             <a:pPr indent="0" marL="0">
               <a:lnSpc>
@@ -10127,6 +10127,58 @@
                 <a:ea typeface="Gilroy" pitchFamily="34" charset="-122"/>
                 <a:cs typeface="Gilroy" pitchFamily="34" charset="-120"/>
               </a:rPr>
+              <a:t>Por eso estas 2 categorías están ocultas por defecto hasta que exista contenido real — sólo se muestran activando un switch puntual.</a:t>
+            </a:r>
+            <a:pPr indent="0" marL="0">
+              <a:lnSpc>
+                <a:spcPct val="125000"/>
+              </a:lnSpc>
+              <a:buNone/>
+            </a:pPr>
+            <a:r>
+              <a:rPr lang="en-US" sz="1250" dirty="0">
+                <a:solidFill>
+                  <a:srgbClr val="49454F"/>
+                </a:solidFill>
+                <a:latin typeface="Gilroy" pitchFamily="34" charset="0"/>
+                <a:ea typeface="Gilroy" pitchFamily="34" charset="-122"/>
+                <a:cs typeface="Gilroy" pitchFamily="34" charset="-120"/>
+              </a:rPr>
+              <a:t>
+</a:t>
+            </a:r>
+            <a:pPr indent="0" marL="0">
+              <a:lnSpc>
+                <a:spcPct val="125000"/>
+              </a:lnSpc>
+              <a:buNone/>
+            </a:pPr>
+            <a:r>
+              <a:rPr lang="en-US" sz="1250" b="1" dirty="0">
+                <a:solidFill>
+                  <a:srgbClr val="152663"/>
+                </a:solidFill>
+                <a:latin typeface="Gilroy" pitchFamily="34" charset="0"/>
+                <a:ea typeface="Gilroy" pitchFamily="34" charset="-122"/>
+                <a:cs typeface="Gilroy" pitchFamily="34" charset="-120"/>
+              </a:rPr>
+              <a:t>•  </a:t>
+            </a:r>
+            <a:pPr indent="0" marL="0">
+              <a:lnSpc>
+                <a:spcPct val="125000"/>
+              </a:lnSpc>
+              <a:buNone/>
+            </a:pPr>
+            <a:r>
+              <a:rPr lang="en-US" sz="1250" dirty="0">
+                <a:solidFill>
+                  <a:srgbClr val="49454F"/>
+                </a:solidFill>
+                <a:latin typeface="Gilroy" pitchFamily="34" charset="0"/>
+                <a:ea typeface="Gilroy" pitchFamily="34" charset="-122"/>
+                <a:cs typeface="Gilroy" pitchFamily="34" charset="-120"/>
+              </a:rPr>
               <a:t>Franquicias y Fulfillment, en cambio, sí tienen contenido confirmado por el negocio.</a:t>
             </a:r>
             <a:endParaRPr lang="en-US" sz="1250" dirty="0"/>
@@ -10754,7 +10806,7 @@
                 <a:ea typeface="Gilroy" pitchFamily="34" charset="-122"/>
                 <a:cs typeface="Gilroy" pitchFamily="34" charset="-120"/>
               </a:rPr>
-              <a:t>6 categorías visibles: Mi Cuenta, Paquetería Nacional, Paquetería Internacional, </a:t>
+              <a:t>4 categorías visibles hoy: Mi Cuenta, Paquetería Nacional, </a:t>
             </a:r>
             <a:pPr indent="0" marL="0">
               <a:lnSpc>
@@ -10788,7 +10840,7 @@
                 <a:ea typeface="Gilroy" pitchFamily="34" charset="-122"/>
                 <a:cs typeface="Gilroy" pitchFamily="34" charset="-120"/>
               </a:rPr>
-              <a:t>, Mis Comunicaciones Digitales, Oficios Judiciales.</a:t>
+              <a:t>, Oficios Judiciales (Paquetería Internacional y Comunicaciones Digitales siguen ocultas por defecto).</a:t>
             </a:r>
             <a:pPr indent="0" marL="0">
               <a:lnSpc>
@@ -10857,7 +10909,7 @@
                 <a:ea typeface="Gilroy" pitchFamily="34" charset="-122"/>
                 <a:cs typeface="Gilroy" pitchFamily="34" charset="-120"/>
               </a:rPr>
-              <a:t>21 gestiones</a:t>
+              <a:t>13 gestiones</a:t>
             </a:r>
             <a:pPr indent="0" marL="0">
               <a:lnSpc>

</xml_diff>